<commit_message>
Update PowerPoint with real model results
</commit_message>
<xml_diff>
--- a/NYC_Taxi_Presentation.pptx
+++ b/NYC_Taxi_Presentation.pptx
@@ -276,7 +276,7 @@
                     <c:v>LightGBM</c:v>
                   </c:pt>
                   <c:pt idx="4">
-                    <c:v>MLP</c:v>
+                    <c:v>XGBoost</c:v>
                   </c:pt>
                 </c:lvl>
               </c:multiLvlStrCache>
@@ -289,19 +289,19 @@
                 <c:formatCode>General</c:formatCode>
                 <c:ptCount val="5"/>
                 <c:pt idx="0">
-                  <c:v>8.5</c:v>
+                  <c:v>13.53</c:v>
                 </c:pt>
                 <c:pt idx="1">
-                  <c:v>6.2</c:v>
+                  <c:v>7.35</c:v>
                 </c:pt>
                 <c:pt idx="2">
-                  <c:v>6</c:v>
+                  <c:v>7.1</c:v>
                 </c:pt>
                 <c:pt idx="3">
-                  <c:v>3.8</c:v>
+                  <c:v>4.74</c:v>
                 </c:pt>
                 <c:pt idx="4">
-                  <c:v>4.9</c:v>
+                  <c:v>4.82</c:v>
                 </c:pt>
               </c:numCache>
             </c:numRef>
@@ -614,7 +614,7 @@
                     <c:v>LightGBM</c:v>
                   </c:pt>
                   <c:pt idx="4">
-                    <c:v>MLP</c:v>
+                    <c:v>XGBoost</c:v>
                   </c:pt>
                 </c:lvl>
               </c:multiLvlStrCache>
@@ -627,19 +627,19 @@
                 <c:formatCode>General</c:formatCode>
                 <c:ptCount val="5"/>
                 <c:pt idx="0">
-                  <c:v>0.51</c:v>
+                  <c:v>0.05</c:v>
                 </c:pt>
                 <c:pt idx="1">
                   <c:v>0.72</c:v>
                 </c:pt>
                 <c:pt idx="2">
-                  <c:v>0.73</c:v>
+                  <c:v>0.74</c:v>
                 </c:pt>
                 <c:pt idx="3">
-                  <c:v>0.87</c:v>
+                  <c:v>0.88</c:v>
                 </c:pt>
                 <c:pt idx="4">
-                  <c:v>0.8</c:v>
+                  <c:v>0.88</c:v>
                 </c:pt>
               </c:numCache>
             </c:numRef>
@@ -2838,7 +2838,7 @@
                 <a:ea typeface="Calibri" pitchFamily="34" charset="-122"/>
                 <a:cs typeface="Calibri" pitchFamily="34" charset="-120"/>
               </a:rPr>
-              <a:t>The LightGBM model successfully predicts NYC yellow taxi trip duration with RMSE = 3.8 min and R² = 0.87 — significantly outperforming the naive distance ÷ speed baseline on all metrics.</a:t>
+              <a:t>The LightGBM model successfully predicts NYC yellow taxi trip duration with RMSE = 4.74 min and R² = 0.88 — significantly outperforming the naive distance ÷ speed baseline on all metrics.</a:t>
             </a:r>
             <a:endParaRPr lang="en-US" sz="1600" dirty="0"/>
           </a:p>
@@ -3917,7 +3917,7 @@
                 <a:ea typeface="Georgia" pitchFamily="34" charset="-122"/>
                 <a:cs typeface="Georgia" pitchFamily="34" charset="-120"/>
               </a:rPr>
-              <a:t>14</a:t>
+              <a:t>3</a:t>
             </a:r>
             <a:endParaRPr lang="en-US" sz="4000" dirty="0"/>
           </a:p>
@@ -3956,7 +3956,7 @@
                 <a:ea typeface="Calibri" pitchFamily="34" charset="-122"/>
                 <a:cs typeface="Calibri" pitchFamily="34" charset="-120"/>
               </a:rPr>
-              <a:t>Months of Data</a:t>
+              <a:t>Months Training</a:t>
             </a:r>
             <a:endParaRPr lang="en-US" sz="1100" dirty="0"/>
           </a:p>
@@ -3973,7 +3973,7 @@
                 <a:ea typeface="Calibri" pitchFamily="34" charset="-122"/>
                 <a:cs typeface="Calibri" pitchFamily="34" charset="-120"/>
               </a:rPr>
-              <a:t>(Jan 2025 – Feb 2026)</a:t>
+              <a:t>(Oct-Dec 2025)</a:t>
             </a:r>
             <a:endParaRPr lang="en-US" sz="1100" dirty="0"/>
           </a:p>
@@ -4044,7 +4044,7 @@
                 <a:ea typeface="Georgia" pitchFamily="34" charset="-122"/>
                 <a:cs typeface="Georgia" pitchFamily="34" charset="-120"/>
               </a:rPr>
-              <a:t>~30M+</a:t>
+              <a:t>11.5M</a:t>
             </a:r>
             <a:endParaRPr lang="en-US" sz="4000" dirty="0"/>
           </a:p>
@@ -4083,7 +4083,7 @@
                 <a:ea typeface="Calibri" pitchFamily="34" charset="-122"/>
                 <a:cs typeface="Calibri" pitchFamily="34" charset="-120"/>
               </a:rPr>
-              <a:t>Trip Records</a:t>
+              <a:t>Training Rows</a:t>
             </a:r>
             <a:endParaRPr lang="en-US" sz="1100" dirty="0"/>
           </a:p>

</xml_diff>